<commit_message>
Checkpoint 2: planted answers and pilot pack rendered and critiqued; critique fixes; renderer, numbers and CSV improvements
</commit_message>
<xml_diff>
--- a/output/archive/BrindlewytheData/Studies/2025/BW25_0600/Readouts/BW25_0600_CLIENT.pptx
+++ b/output/archive/BrindlewytheData/Studies/2025/BW25_0600/Readouts/BW25_0600_CLIENT.pptx
@@ -511,6 +511,76 @@
           <a:p>
             <a:r>
               <a:t>Plate acceptance first, then ranking, then the decision. Keep mechanism out of it.</a:t>
+            </a:r>
+          </a:p>
+        </p:txBody>
+      </p:sp>
+      <p:sp>
+        <p:nvSpPr>
+          <p:cNvPr id="4" name="Slide Number Placeholder 3"/>
+          <p:cNvSpPr>
+            <a:spLocks noGrp="1"/>
+          </p:cNvSpPr>
+          <p:nvPr>
+            <p:ph type="sldNum" idx="5" sz="quarter"/>
+          </p:nvPr>
+        </p:nvSpPr>
+        <p:spPr/>
+      </p:sp>
+    </p:spTree>
+  </p:cSld>
+  <p:clrMapOvr>
+    <a:masterClrMapping/>
+  </p:clrMapOvr>
+</p:notes>
+</file>
+
+<file path=ppt/notesSlides/notesSlide2.xml><?xml version="1.0" encoding="utf-8"?>
+<p:notes xmlns:a="http://schemas.openxmlformats.org/drawingml/2006/main" xmlns:p="http://schemas.openxmlformats.org/presentationml/2006/main" xmlns:r="http://schemas.openxmlformats.org/officeDocument/2006/relationships">
+  <p:cSld>
+    <p:spTree>
+      <p:nvGrpSpPr>
+        <p:cNvPr id="1" name=""/>
+        <p:cNvGrpSpPr/>
+        <p:nvPr/>
+      </p:nvGrpSpPr>
+      <p:grpSpPr>
+        <a:xfrm>
+          <a:off x="0" y="0"/>
+          <a:ext cx="0" cy="0"/>
+          <a:chOff x="0" y="0"/>
+          <a:chExt cx="0" cy="0"/>
+        </a:xfrm>
+      </p:grpSpPr>
+      <p:sp>
+        <p:nvSpPr>
+          <p:cNvPr id="2" name="Slide Image Placeholder 1"/>
+          <p:cNvSpPr>
+            <a:spLocks noGrp="1"/>
+          </p:cNvSpPr>
+          <p:nvPr>
+            <p:ph type="sldImg" idx="2"/>
+          </p:nvPr>
+        </p:nvSpPr>
+        <p:spPr/>
+      </p:sp>
+      <p:sp>
+        <p:nvSpPr>
+          <p:cNvPr id="3" name="Notes Placeholder 2"/>
+          <p:cNvSpPr>
+            <a:spLocks noGrp="1"/>
+          </p:cNvSpPr>
+          <p:nvPr>
+            <p:ph type="body" idx="3" sz="quarter"/>
+          </p:nvPr>
+        </p:nvSpPr>
+        <p:spPr/>
+        <p:txBody>
+          <a:bodyPr/>
+          <a:lstStyle/>
+          <a:p>
+            <a:r>
+              <a:t>Tie-break between the two one-hit compounds was primary potency (see slide 4 and the run sheets).</a:t>
             </a:r>
           </a:p>
         </p:txBody>
@@ -3710,7 +3780,7 @@
               <a:rPr sz="1700">
                 <a:latin typeface="Arial"/>
               </a:rPr>
-              <a:t>Best IC50 8.7 nM; staurosporine control within range on every plate</a:t>
+              <a:t>Best IC50 8.7 nM</a:t>
             </a:r>
           </a:p>
           <a:p>
@@ -3728,7 +3798,7 @@
               <a:rPr sz="2000">
                 <a:latin typeface="Arial"/>
               </a:rPr>
-              <a:t>Recommendation: progress the compound with the narrowest off-target fingerprint (slide 7)</a:t>
+              <a:t>Decision: Avernelwick selected AP02-01430 for the next chemistry round (slide 7)</a:t>
             </a:r>
           </a:p>
         </p:txBody>
@@ -3888,7 +3958,7 @@
               <a:rPr sz="2000">
                 <a:latin typeface="Arial"/>
               </a:rPr>
-              <a:t>All plates: Z' ≥ 0.6, staurosporine IC50 within historical range</a:t>
+              <a:t>Acceptance criteria as agreed in the study plan: Z' and staurosporine IC50 within the historical range on every plate</a:t>
             </a:r>
           </a:p>
           <a:p>
@@ -3897,7 +3967,7 @@
               <a:rPr sz="2000">
                 <a:latin typeface="Arial"/>
               </a:rPr>
-              <a:t>No compound showed signal interference in the counter-read</a:t>
+              <a:t>All plates accepted; per-plate values are in the run sheets sent with this readout</a:t>
             </a:r>
           </a:p>
           <a:p>
@@ -3906,7 +3976,7 @@
               <a:rPr sz="2000">
                 <a:latin typeface="Arial"/>
               </a:rPr>
-              <a:t>Two compounds repeated on day 2 after a dispensing error; repeat data reported</a:t>
+              <a:t>No compound flagged for signal interference in the counter-read</a:t>
             </a:r>
           </a:p>
         </p:txBody>
@@ -7000,64 +7070,14 @@
                 </a:solidFill>
                 <a:latin typeface="Arial"/>
               </a:rPr>
-              <a:t>Ranking</a:t>
-            </a:r>
-          </a:p>
-        </p:txBody>
-      </p:sp>
-      <p:sp>
-        <p:nvSpPr>
-          <p:cNvPr id="3" name="Content Placeholder 2"/>
-          <p:cNvSpPr>
-            <a:spLocks noGrp="1"/>
-          </p:cNvSpPr>
-          <p:nvPr>
-            <p:ph idx="1"/>
-          </p:nvPr>
-        </p:nvSpPr>
-        <p:spPr>
-          <a:xfrm>
-            <a:off x="457200" y="1280160"/>
-            <a:ext cx="11277295" cy="4937760"/>
-          </a:xfrm>
-        </p:spPr>
-        <p:txBody>
-          <a:bodyPr wrap="square">
-            <a:noAutofit/>
-          </a:bodyPr>
-          <a:lstStyle/>
-          <a:p>
-            <a:pPr/>
-            <a:r>
-              <a:rPr sz="2000">
-                <a:latin typeface="Arial"/>
-              </a:rPr>
-              <a:t>Potency alone does not separate the top compounds</a:t>
-            </a:r>
-          </a:p>
-          <a:p>
-            <a:pPr/>
-            <a:r>
-              <a:rPr sz="2000">
-                <a:latin typeface="Arial"/>
-              </a:rPr>
-              <a:t>The off-target fingerprint does: one compound hits fewer panel kinases above 50%</a:t>
-            </a:r>
-          </a:p>
-          <a:p>
-            <a:pPr/>
-            <a:r>
-              <a:rPr sz="2000">
-                <a:latin typeface="Arial"/>
-              </a:rPr>
-              <a:t>Two potent compounds carry broad off-target inhibition and are not recommended</a:t>
-            </a:r>
-          </a:p>
-        </p:txBody>
-      </p:sp>
-      <p:sp>
-        <p:nvSpPr>
-          <p:cNvPr id="4" name="Rectangle 3"/>
+              <a:t>Ranking and decision</a:t>
+            </a:r>
+          </a:p>
+        </p:txBody>
+      </p:sp>
+      <p:sp>
+        <p:nvSpPr>
+          <p:cNvPr id="3" name="Rectangle 2"/>
           <p:cNvSpPr/>
           <p:nvPr/>
         </p:nvSpPr>
@@ -7098,6 +7118,383 @@
           </a:p>
         </p:txBody>
       </p:sp>
+      <p:graphicFrame>
+        <p:nvGraphicFramePr>
+          <p:cNvPr id="4" name="Table 3"/>
+          <p:cNvGraphicFramePr>
+            <a:graphicFrameLocks noGrp="1"/>
+          </p:cNvGraphicFramePr>
+          <p:nvPr/>
+        </p:nvGraphicFramePr>
+        <p:xfrm>
+          <a:off x="457200" y="1280160"/>
+          <a:ext cx="11277295" cy="1920240"/>
+        </p:xfrm>
+        <a:graphic>
+          <a:graphicData uri="http://schemas.openxmlformats.org/drawingml/2006/table">
+            <a:tbl>
+              <a:tblPr firstRow="1" bandRow="1">
+                <a:tableStyleId>{5C22544A-7EE6-4342-B048-85BDC9FD1C3A}</a:tableStyleId>
+              </a:tblPr>
+              <a:tblGrid>
+                <a:gridCol w="3759098"/>
+                <a:gridCol w="3759098"/>
+                <a:gridCol w="3759099"/>
+              </a:tblGrid>
+              <a:tr h="274320">
+                <a:tc>
+                  <a:txBody>
+                    <a:bodyPr/>
+                    <a:lstStyle/>
+                    <a:p>
+                      <a:r>
+                        <a:rPr sz="1400" b="1">
+                          <a:solidFill>
+                            <a:srgbClr val="FFFFFF"/>
+                          </a:solidFill>
+                          <a:latin typeface="Arial"/>
+                        </a:rPr>
+                        <a:t>Compound</a:t>
+                      </a:r>
+                    </a:p>
+                  </a:txBody>
+                  <a:tcPr>
+                    <a:solidFill>
+                      <a:srgbClr val="183C4C"/>
+                    </a:solidFill>
+                  </a:tcPr>
+                </a:tc>
+                <a:tc>
+                  <a:txBody>
+                    <a:bodyPr/>
+                    <a:lstStyle/>
+                    <a:p>
+                      <a:r>
+                        <a:rPr sz="1400" b="1">
+                          <a:solidFill>
+                            <a:srgbClr val="FFFFFF"/>
+                          </a:solidFill>
+                          <a:latin typeface="Arial"/>
+                        </a:rPr>
+                        <a:t>Off-target kinases &gt;50% at 1 µM</a:t>
+                      </a:r>
+                    </a:p>
+                  </a:txBody>
+                  <a:tcPr>
+                    <a:solidFill>
+                      <a:srgbClr val="183C4C"/>
+                    </a:solidFill>
+                  </a:tcPr>
+                </a:tc>
+                <a:tc>
+                  <a:txBody>
+                    <a:bodyPr/>
+                    <a:lstStyle/>
+                    <a:p>
+                      <a:r>
+                        <a:rPr sz="1400" b="1">
+                          <a:solidFill>
+                            <a:srgbClr val="FFFFFF"/>
+                          </a:solidFill>
+                          <a:latin typeface="Arial"/>
+                        </a:rPr>
+                        <a:t>Decision</a:t>
+                      </a:r>
+                    </a:p>
+                  </a:txBody>
+                  <a:tcPr>
+                    <a:solidFill>
+                      <a:srgbClr val="183C4C"/>
+                    </a:solidFill>
+                  </a:tcPr>
+                </a:tc>
+              </a:tr>
+              <a:tr h="274320">
+                <a:tc>
+                  <a:txBody>
+                    <a:bodyPr/>
+                    <a:lstStyle/>
+                    <a:p>
+                      <a:r>
+                        <a:rPr sz="1400">
+                          <a:latin typeface="Arial"/>
+                        </a:rPr>
+                        <a:t>AP02-01430</a:t>
+                      </a:r>
+                    </a:p>
+                  </a:txBody>
+                  <a:tcPr/>
+                </a:tc>
+                <a:tc>
+                  <a:txBody>
+                    <a:bodyPr/>
+                    <a:lstStyle/>
+                    <a:p>
+                      <a:r>
+                        <a:rPr sz="1400">
+                          <a:latin typeface="Arial"/>
+                        </a:rPr>
+                        <a:t>1 (ABL1)</a:t>
+                      </a:r>
+                    </a:p>
+                  </a:txBody>
+                  <a:tcPr/>
+                </a:tc>
+                <a:tc>
+                  <a:txBody>
+                    <a:bodyPr/>
+                    <a:lstStyle/>
+                    <a:p>
+                      <a:r>
+                        <a:rPr sz="1400">
+                          <a:latin typeface="Arial"/>
+                        </a:rPr>
+                        <a:t>Selected by Avernelwick: narrowest fingerprint and more potent of the two one-hit compounds</a:t>
+                      </a:r>
+                    </a:p>
+                  </a:txBody>
+                  <a:tcPr/>
+                </a:tc>
+              </a:tr>
+              <a:tr h="274320">
+                <a:tc>
+                  <a:txBody>
+                    <a:bodyPr/>
+                    <a:lstStyle/>
+                    <a:p>
+                      <a:r>
+                        <a:rPr sz="1400">
+                          <a:latin typeface="Arial"/>
+                        </a:rPr>
+                        <a:t>AP02-01410</a:t>
+                      </a:r>
+                    </a:p>
+                  </a:txBody>
+                  <a:tcPr/>
+                </a:tc>
+                <a:tc>
+                  <a:txBody>
+                    <a:bodyPr/>
+                    <a:lstStyle/>
+                    <a:p>
+                      <a:r>
+                        <a:rPr sz="1400">
+                          <a:latin typeface="Arial"/>
+                        </a:rPr>
+                        <a:t>1 (KDR)</a:t>
+                      </a:r>
+                    </a:p>
+                  </a:txBody>
+                  <a:tcPr/>
+                </a:tc>
+                <a:tc>
+                  <a:txBody>
+                    <a:bodyPr/>
+                    <a:lstStyle/>
+                    <a:p>
+                      <a:r>
+                        <a:rPr sz="1400">
+                          <a:latin typeface="Arial"/>
+                        </a:rPr>
+                        <a:t>Back-up: same fingerprint width, weaker primary potency</a:t>
+                      </a:r>
+                    </a:p>
+                  </a:txBody>
+                  <a:tcPr/>
+                </a:tc>
+              </a:tr>
+              <a:tr h="274320">
+                <a:tc>
+                  <a:txBody>
+                    <a:bodyPr/>
+                    <a:lstStyle/>
+                    <a:p>
+                      <a:r>
+                        <a:rPr sz="1400">
+                          <a:latin typeface="Arial"/>
+                        </a:rPr>
+                        <a:t>AP02-01416</a:t>
+                      </a:r>
+                    </a:p>
+                  </a:txBody>
+                  <a:tcPr/>
+                </a:tc>
+                <a:tc>
+                  <a:txBody>
+                    <a:bodyPr/>
+                    <a:lstStyle/>
+                    <a:p>
+                      <a:r>
+                        <a:rPr sz="1400">
+                          <a:latin typeface="Arial"/>
+                        </a:rPr>
+                        <a:t>4</a:t>
+                      </a:r>
+                    </a:p>
+                  </a:txBody>
+                  <a:tcPr/>
+                </a:tc>
+                <a:tc>
+                  <a:txBody>
+                    <a:bodyPr/>
+                    <a:lstStyle/>
+                    <a:p>
+                      <a:r>
+                        <a:rPr sz="1400">
+                          <a:latin typeface="Arial"/>
+                        </a:rPr>
+                        <a:t>Not progressed</a:t>
+                      </a:r>
+                    </a:p>
+                  </a:txBody>
+                  <a:tcPr/>
+                </a:tc>
+              </a:tr>
+              <a:tr h="274320">
+                <a:tc>
+                  <a:txBody>
+                    <a:bodyPr/>
+                    <a:lstStyle/>
+                    <a:p>
+                      <a:r>
+                        <a:rPr sz="1400">
+                          <a:latin typeface="Arial"/>
+                        </a:rPr>
+                        <a:t>AP02-01400</a:t>
+                      </a:r>
+                    </a:p>
+                  </a:txBody>
+                  <a:tcPr/>
+                </a:tc>
+                <a:tc>
+                  <a:txBody>
+                    <a:bodyPr/>
+                    <a:lstStyle/>
+                    <a:p>
+                      <a:r>
+                        <a:rPr sz="1400">
+                          <a:latin typeface="Arial"/>
+                        </a:rPr>
+                        <a:t>3</a:t>
+                      </a:r>
+                    </a:p>
+                  </a:txBody>
+                  <a:tcPr/>
+                </a:tc>
+                <a:tc>
+                  <a:txBody>
+                    <a:bodyPr/>
+                    <a:lstStyle/>
+                    <a:p>
+                      <a:r>
+                        <a:rPr sz="1400">
+                          <a:latin typeface="Arial"/>
+                        </a:rPr>
+                        <a:t>Not progressed</a:t>
+                      </a:r>
+                    </a:p>
+                  </a:txBody>
+                  <a:tcPr/>
+                </a:tc>
+              </a:tr>
+              <a:tr h="274320">
+                <a:tc>
+                  <a:txBody>
+                    <a:bodyPr/>
+                    <a:lstStyle/>
+                    <a:p>
+                      <a:r>
+                        <a:rPr sz="1400">
+                          <a:latin typeface="Arial"/>
+                        </a:rPr>
+                        <a:t>AP02-01418</a:t>
+                      </a:r>
+                    </a:p>
+                  </a:txBody>
+                  <a:tcPr/>
+                </a:tc>
+                <a:tc>
+                  <a:txBody>
+                    <a:bodyPr/>
+                    <a:lstStyle/>
+                    <a:p>
+                      <a:r>
+                        <a:rPr sz="1400">
+                          <a:latin typeface="Arial"/>
+                        </a:rPr>
+                        <a:t>6</a:t>
+                      </a:r>
+                    </a:p>
+                  </a:txBody>
+                  <a:tcPr/>
+                </a:tc>
+                <a:tc>
+                  <a:txBody>
+                    <a:bodyPr/>
+                    <a:lstStyle/>
+                    <a:p>
+                      <a:r>
+                        <a:rPr sz="1400">
+                          <a:latin typeface="Arial"/>
+                        </a:rPr>
+                        <a:t>Set aside: broad off-target inhibition</a:t>
+                      </a:r>
+                    </a:p>
+                  </a:txBody>
+                  <a:tcPr/>
+                </a:tc>
+              </a:tr>
+              <a:tr h="274320">
+                <a:tc>
+                  <a:txBody>
+                    <a:bodyPr/>
+                    <a:lstStyle/>
+                    <a:p>
+                      <a:r>
+                        <a:rPr sz="1400">
+                          <a:latin typeface="Arial"/>
+                        </a:rPr>
+                        <a:t>AP02-01428</a:t>
+                      </a:r>
+                    </a:p>
+                  </a:txBody>
+                  <a:tcPr/>
+                </a:tc>
+                <a:tc>
+                  <a:txBody>
+                    <a:bodyPr/>
+                    <a:lstStyle/>
+                    <a:p>
+                      <a:r>
+                        <a:rPr sz="1400">
+                          <a:latin typeface="Arial"/>
+                        </a:rPr>
+                        <a:t>6</a:t>
+                      </a:r>
+                    </a:p>
+                  </a:txBody>
+                  <a:tcPr/>
+                </a:tc>
+                <a:tc>
+                  <a:txBody>
+                    <a:bodyPr/>
+                    <a:lstStyle/>
+                    <a:p>
+                      <a:r>
+                        <a:rPr sz="1400">
+                          <a:latin typeface="Arial"/>
+                        </a:rPr>
+                        <a:t>Set aside: broad off-target inhibition</a:t>
+                      </a:r>
+                    </a:p>
+                  </a:txBody>
+                  <a:tcPr/>
+                </a:tc>
+              </a:tr>
+            </a:tbl>
+          </a:graphicData>
+        </a:graphic>
+      </p:graphicFrame>
       <p:sp>
         <p:nvSpPr>
           <p:cNvPr id="5" name="TextBox 4"/>
@@ -7362,7 +7759,7 @@
               <a:rPr sz="2000">
                 <a:latin typeface="Arial"/>
               </a:rPr>
-              <a:t>Avernelwick to choose the reserve compound for the next chemistry round</a:t>
+              <a:t>Avernelwick confirmed AP02-01430 as the reserve for the next medicinal chemistry round (call, 26 January)</a:t>
             </a:r>
           </a:p>
           <a:p>
@@ -7371,7 +7768,7 @@
               <a:rPr sz="2000">
                 <a:latin typeface="Arial"/>
               </a:rPr>
-              <a:t>Optional: full concentration response on the off-targets above 50%</a:t>
+              <a:t>AP02-01410 kept as back-up</a:t>
             </a:r>
           </a:p>
           <a:p>
@@ -7380,7 +7777,7 @@
               <a:rPr sz="2000">
                 <a:latin typeface="Arial"/>
               </a:rPr>
-              <a:t>Data package: run sheets and summary workbook sent with this readout</a:t>
+              <a:t>Optional: full concentration response on ABL1 for AP02-01430</a:t>
             </a:r>
           </a:p>
           <a:p>

</xml_diff>